<commit_message>
RODS epidemic threshold is 11% (was 10%); annotate the threshold on the web pages
- backtest.DEFAULT_THRESHOLDS rods_ili_pct = 11.0; RODS report and summaries regenerated
- Weekly page: red dashed threshold line on the RODS fan chart, KPI badge when above
  threshold, narrative and outlook use the configured value
- Backtest page footnote and report/deck text now read the configured threshold

Co-Authored-By: Claude Fable 5.1 <noreply@anthropic.com>
</commit_message>
<xml_diff>
--- a/outputs/slides/forecast-teller_成果報告_2026-09-17.pptx
+++ b/outputs/slides/forecast-teller_成果報告_2026-09-17.pptx
@@ -9016,7 +9016,7 @@
                 <a:ea typeface="PingFang TC"/>
                 <a:cs typeface="PingFang TC"/>
               </a:rPr>
-              <a:t>最佳 WIS 0.63 個百分點，相對 naive 0.88；以流行閾值 10% 計，閾值命中率（敏感度）0.92、誤報率 0.26（naive 0.89 / 0.30）。</a:t>
+              <a:t>最佳 WIS 0.63 個百分點，相對 naive 0.88；以流行閾值 10% 計，閾值命中率（敏感度）0.82、誤報率 0.19（naive 0.89 / 0.30）。</a:t>
             </a:r>
           </a:p>
           <a:p>
@@ -9432,7 +9432,7 @@
                 <a:ea typeface="PingFang TC"/>
                 <a:cs typeface="PingFang TC"/>
               </a:rPr>
-              <a:t>疫情處於上升期、活動度高：門診人次較前一週 +18%，RODS 急診類流感% 12.0%（連續 7 週高於流行閾值）；模型預期第 2 週（2026-09-20 起）前後觸頂，之後緩降，下週續升機率約 75%。</a:t>
+              <a:t>疫情處於上升期、活動度高：門診人次較前一週 +18%，RODS 急診類流感% 12.0%（連續 2 週高於流行閾值）；模型預期第 2 週（2026-09-20 起）前後觸頂，之後緩降，下週續升機率約 75%。</a:t>
             </a:r>
           </a:p>
         </p:txBody>

</xml_diff>

<commit_message>
Weekly page: RODS 11% threshold line and badge; deck and footnotes read the configured threshold
Co-Authored-By: Claude Fable 5.1 <noreply@anthropic.com>
</commit_message>
<xml_diff>
--- a/outputs/slides/forecast-teller_成果報告_2026-09-17.pptx
+++ b/outputs/slides/forecast-teller_成果報告_2026-09-17.pptx
@@ -6265,7 +6265,7 @@
                 <a:ea typeface="PingFang TC"/>
                 <a:cs typeface="PingFang TC"/>
               </a:rPr>
-              <a:t>WIS（加權區間分數，主指標）、MAE、MAPE、MASE、80%/60% 區間涵蓋率、方向命中率、±10% 容忍帶命中率、閾值命中率與誤報率（門診以第 75 百分位、RODS 以流行閾值 10%）。</a:t>
+              <a:t>WIS（加權區間分數，主指標）、MAE、MAPE、MASE、80%/60% 區間涵蓋率、方向命中率、±10% 容忍帶命中率、閾值命中率與誤報率（門診以第 75 百分位、RODS 以流行閾值 11%）。</a:t>
             </a:r>
           </a:p>
           <a:p>
@@ -9016,7 +9016,7 @@
                 <a:ea typeface="PingFang TC"/>
                 <a:cs typeface="PingFang TC"/>
               </a:rPr>
-              <a:t>最佳 WIS 0.63 個百分點，相對 naive 0.88；以流行閾值 10% 計，閾值命中率（敏感度）0.82、誤報率 0.19（naive 0.89 / 0.30）。</a:t>
+              <a:t>最佳 WIS 0.63 個百分點，相對 naive 0.88；以流行閾值 11% 計，閾值命中率（敏感度）0.82、誤報率 0.19（naive 0.78 / 0.24）。</a:t>
             </a:r>
           </a:p>
           <a:p>
@@ -9696,7 +9696,7 @@
                 <a:ea typeface="PingFang TC"/>
                 <a:cs typeface="PingFang TC"/>
               </a:rPr>
-              <a:t>維持在 10% 以上的機率約 95%</a:t>
+              <a:t>維持在流行閾值 11% 以上的機率第 1 週約 95%、第 4 週約 80%</a:t>
             </a:r>
           </a:p>
         </p:txBody>

</xml_diff>